<commit_message>
docs: update LANL ML presentation and speaker script
</commit_message>
<xml_diff>
--- a/presentation_ml_final/LANL_ML_Final_Project_Presentation.pptx
+++ b/presentation_ml_final/LANL_ML_Final_Project_Presentation.pptx
@@ -1114,26 +1114,9 @@
           <a:bodyPr/>
           <a:lstStyle/>
           <a:p>
-            <a:pPr marL="0" marR="0" lvl="0" indent="0" algn="l" defTabSz="914400" rtl="0" eaLnBrk="1" fontAlgn="auto" latinLnBrk="0" hangingPunct="1">
-              <a:lnSpc>
-                <a:spcPct val="100000"/>
-              </a:lnSpc>
-              <a:spcBef>
-                <a:spcPts val="0"/>
-              </a:spcBef>
-              <a:spcAft>
-                <a:spcPts val="0"/>
-              </a:spcAft>
-              <a:buClrTx/>
-              <a:buSzTx/>
-              <a:buFontTx/>
-              <a:buNone/>
-              <a:tabLst/>
-              <a:defRPr/>
-            </a:pPr>
             <a:r>
               <a:rPr lang="en-US" dirty="0"/>
-              <a:t>"Honest limitations: the streaming ingest is simulated, not a real Kinesis consumer. The model's probabilities are good for ranking but not calibrated as true frequencies — we'd want reliability diagrams and Platt scaling before quoting percentages to a CISO. k-fold was not used, for reasons I've explained. The GenAI comparison was not completed. My recommendation: deploy </a:t>
+              <a:t>"Honest limitations: the streaming ingest is simulated, not a real Kinesis consumer. The model's probabilities are good for ranking but not calibrated as true frequencies — we'd want reliability diagrams and Platt scaling before quoting percentages. “The model’s biggest limitation is that this is a rare-event problem with only 596 positives. I used a stratified 60/20/20 split because a strict chronological split left validation and test with too few positives to evaluate, but that means the evaluation is not a perfect forward-in-time deployment simulation. </a:t>
             </a:r>
             <a:r>
               <a:rPr lang="en-US" dirty="0" err="1"/>
@@ -1141,11 +1124,12 @@
             </a:r>
             <a:r>
               <a:rPr lang="en-US" dirty="0"/>
-              <a:t> at the cost-optimal threshold, pair every alert with its SHAP explanation so analysts understand why, and use the counterfactual recommender as the first-line remediation guide. The model doesn't replace analysts — it tells them where to look and why."</a:t>
-            </a:r>
-          </a:p>
-          <a:p>
-            <a:endParaRPr lang="en-US" dirty="0"/>
+              <a:t> performs much better than random and much better than logistic regression, especially on PR-AUC, but the absolute PR-AUC is still low because the positive rate is only about 0.0043%. The confusion matrix also shows that at threshold 0.10, the model catches some attacks but misses many and still creates analyst workload. So I would not frame this as an autonomous attack detector. I would frame it as a SOC triage model that ranks risky host-hours for analyst review. </a:t>
+            </a:r>
+            <a:r>
+              <a:rPr lang="en-US"/>
+              <a:t>Future work would include external validation, probability calibration, stronger temporal validation, sequence/graph features, and threshold tuning based on actual SOC capacity.”</a:t>
+            </a:r>
           </a:p>
         </p:txBody>
       </p:sp>

</xml_diff>